<commit_message>
Update A-Share Blast Lab / 2026-10-26 daily-18:05
</commit_message>
<xml_diff>
--- a/assets/多空阶段简报_2026-10-26.pptx
+++ b/assets/多空阶段简报_2026-10-26.pptx
@@ -193,16 +193,16 @@
                 <c:formatCode>General</c:formatCode>
                 <c:ptCount val="4"/>
                 <c:pt idx="0">
-                  <c:v>1</c:v>
+                  <c:v>2</c:v>
                 </c:pt>
                 <c:pt idx="1">
-                  <c:v>3</c:v>
+                  <c:v>1</c:v>
                 </c:pt>
                 <c:pt idx="2">
                   <c:v>0</c:v>
                 </c:pt>
                 <c:pt idx="3">
-                  <c:v>13</c:v>
+                  <c:v>14</c:v>
                 </c:pt>
               </c:numCache>
             </c:numRef>
@@ -328,31 +328,31 @@
               <c:strCache>
                 <c:ptCount val="9"/>
                 <c:pt idx="0">
+                  <c:v>机器人</c:v>
+                </c:pt>
+                <c:pt idx="1">
+                  <c:v>药</c:v>
+                </c:pt>
+                <c:pt idx="2">
+                  <c:v>AI应用</c:v>
+                </c:pt>
+                <c:pt idx="3">
+                  <c:v>互金证券</c:v>
+                </c:pt>
+                <c:pt idx="4">
                   <c:v>算力</c:v>
                 </c:pt>
-                <c:pt idx="1">
-                  <c:v>AI应用</c:v>
+                <c:pt idx="5">
+                  <c:v>半导体芯片</c:v>
                 </c:pt>
-                <c:pt idx="2">
-                  <c:v>机器人</c:v>
+                <c:pt idx="6">
+                  <c:v>电力</c:v>
                 </c:pt>
-                <c:pt idx="3">
-                  <c:v>药</c:v>
-                </c:pt>
-                <c:pt idx="4">
-                  <c:v>互金证券</c:v>
-                </c:pt>
-                <c:pt idx="5">
+                <c:pt idx="7">
                   <c:v>商业航天</c:v>
                 </c:pt>
-                <c:pt idx="6">
-                  <c:v>半导体芯片</c:v>
-                </c:pt>
-                <c:pt idx="7">
+                <c:pt idx="8">
                   <c:v>PCB</c:v>
-                </c:pt>
-                <c:pt idx="8">
-                  <c:v>半导体设备</c:v>
                 </c:pt>
               </c:strCache>
             </c:strRef>
@@ -364,31 +364,31 @@
                 <c:formatCode>General</c:formatCode>
                 <c:ptCount val="9"/>
                 <c:pt idx="0">
-                  <c:v>2</c:v>
+                  <c:v>4</c:v>
                 </c:pt>
                 <c:pt idx="1">
-                  <c:v>8</c:v>
+                  <c:v>14</c:v>
                 </c:pt>
                 <c:pt idx="2">
-                  <c:v>4</c:v>
+                  <c:v>6</c:v>
                 </c:pt>
                 <c:pt idx="3">
-                  <c:v>15</c:v>
+                  <c:v>3</c:v>
                 </c:pt>
                 <c:pt idx="4">
+                  <c:v>0</c:v>
+                </c:pt>
+                <c:pt idx="5">
                   <c:v>1</c:v>
                 </c:pt>
-                <c:pt idx="5">
-                  <c:v>4</c:v>
-                </c:pt>
                 <c:pt idx="6">
-                  <c:v>1</c:v>
+                  <c:v>2</c:v>
                 </c:pt>
                 <c:pt idx="7">
                   <c:v>1</c:v>
                 </c:pt>
                 <c:pt idx="8">
-                  <c:v>1</c:v>
+                  <c:v>0</c:v>
                 </c:pt>
               </c:numCache>
             </c:numRef>
@@ -445,31 +445,31 @@
               <c:strCache>
                 <c:ptCount val="9"/>
                 <c:pt idx="0">
+                  <c:v>机器人</c:v>
+                </c:pt>
+                <c:pt idx="1">
+                  <c:v>药</c:v>
+                </c:pt>
+                <c:pt idx="2">
+                  <c:v>AI应用</c:v>
+                </c:pt>
+                <c:pt idx="3">
+                  <c:v>互金证券</c:v>
+                </c:pt>
+                <c:pt idx="4">
                   <c:v>算力</c:v>
                 </c:pt>
-                <c:pt idx="1">
-                  <c:v>AI应用</c:v>
+                <c:pt idx="5">
+                  <c:v>半导体芯片</c:v>
                 </c:pt>
-                <c:pt idx="2">
-                  <c:v>机器人</c:v>
+                <c:pt idx="6">
+                  <c:v>电力</c:v>
                 </c:pt>
-                <c:pt idx="3">
-                  <c:v>药</c:v>
-                </c:pt>
-                <c:pt idx="4">
-                  <c:v>互金证券</c:v>
-                </c:pt>
-                <c:pt idx="5">
+                <c:pt idx="7">
                   <c:v>商业航天</c:v>
                 </c:pt>
-                <c:pt idx="6">
-                  <c:v>半导体芯片</c:v>
-                </c:pt>
-                <c:pt idx="7">
+                <c:pt idx="8">
                   <c:v>PCB</c:v>
-                </c:pt>
-                <c:pt idx="8">
-                  <c:v>半导体设备</c:v>
                 </c:pt>
               </c:strCache>
             </c:strRef>
@@ -481,25 +481,25 @@
                 <c:formatCode>General</c:formatCode>
                 <c:ptCount val="9"/>
                 <c:pt idx="0">
-                  <c:v>10</c:v>
+                  <c:v>5</c:v>
                 </c:pt>
                 <c:pt idx="1">
-                  <c:v>5</c:v>
+                  <c:v>7</c:v>
                 </c:pt>
                 <c:pt idx="2">
-                  <c:v>5</c:v>
+                  <c:v>3</c:v>
                 </c:pt>
                 <c:pt idx="3">
-                  <c:v>8</c:v>
+                  <c:v>1</c:v>
                 </c:pt>
                 <c:pt idx="4">
-                  <c:v>2</c:v>
+                  <c:v>5</c:v>
                 </c:pt>
                 <c:pt idx="5">
                   <c:v>2</c:v>
                 </c:pt>
                 <c:pt idx="6">
-                  <c:v>2</c:v>
+                  <c:v>0</c:v>
                 </c:pt>
                 <c:pt idx="7">
                   <c:v>1</c:v>
@@ -539,31 +539,31 @@
               <c:strCache>
                 <c:ptCount val="9"/>
                 <c:pt idx="0">
+                  <c:v>机器人</c:v>
+                </c:pt>
+                <c:pt idx="1">
+                  <c:v>药</c:v>
+                </c:pt>
+                <c:pt idx="2">
+                  <c:v>AI应用</c:v>
+                </c:pt>
+                <c:pt idx="3">
+                  <c:v>互金证券</c:v>
+                </c:pt>
+                <c:pt idx="4">
                   <c:v>算力</c:v>
                 </c:pt>
-                <c:pt idx="1">
-                  <c:v>AI应用</c:v>
+                <c:pt idx="5">
+                  <c:v>半导体芯片</c:v>
                 </c:pt>
-                <c:pt idx="2">
-                  <c:v>机器人</c:v>
+                <c:pt idx="6">
+                  <c:v>电力</c:v>
                 </c:pt>
-                <c:pt idx="3">
-                  <c:v>药</c:v>
-                </c:pt>
-                <c:pt idx="4">
-                  <c:v>互金证券</c:v>
-                </c:pt>
-                <c:pt idx="5">
+                <c:pt idx="7">
                   <c:v>商业航天</c:v>
                 </c:pt>
-                <c:pt idx="6">
-                  <c:v>半导体芯片</c:v>
-                </c:pt>
-                <c:pt idx="7">
+                <c:pt idx="8">
                   <c:v>PCB</c:v>
-                </c:pt>
-                <c:pt idx="8">
-                  <c:v>半导体设备</c:v>
                 </c:pt>
               </c:strCache>
             </c:strRef>
@@ -578,13 +578,13 @@
                   <c:v>0</c:v>
                 </c:pt>
                 <c:pt idx="1">
-                  <c:v>0</c:v>
+                  <c:v>1</c:v>
                 </c:pt>
                 <c:pt idx="2">
                   <c:v>0</c:v>
                 </c:pt>
                 <c:pt idx="3">
-                  <c:v>1</c:v>
+                  <c:v>0</c:v>
                 </c:pt>
                 <c:pt idx="4">
                   <c:v>0</c:v>
@@ -593,7 +593,7 @@
                   <c:v>0</c:v>
                 </c:pt>
                 <c:pt idx="6">
-                  <c:v>0</c:v>
+                  <c:v>1</c:v>
                 </c:pt>
                 <c:pt idx="7">
                   <c:v>0</c:v>
@@ -774,31 +774,31 @@
               <c:strCache>
                 <c:ptCount val="9"/>
                 <c:pt idx="0">
+                  <c:v>机器人</c:v>
+                </c:pt>
+                <c:pt idx="1">
+                  <c:v>药</c:v>
+                </c:pt>
+                <c:pt idx="2">
+                  <c:v>AI应用</c:v>
+                </c:pt>
+                <c:pt idx="3">
+                  <c:v>互金证券</c:v>
+                </c:pt>
+                <c:pt idx="4">
                   <c:v>算力</c:v>
                 </c:pt>
-                <c:pt idx="1">
-                  <c:v>AI应用</c:v>
+                <c:pt idx="5">
+                  <c:v>半导体芯片</c:v>
                 </c:pt>
-                <c:pt idx="2">
-                  <c:v>机器人</c:v>
+                <c:pt idx="6">
+                  <c:v>电力</c:v>
                 </c:pt>
-                <c:pt idx="3">
-                  <c:v>药</c:v>
-                </c:pt>
-                <c:pt idx="4">
-                  <c:v>互金证券</c:v>
-                </c:pt>
-                <c:pt idx="5">
+                <c:pt idx="7">
                   <c:v>商业航天</c:v>
                 </c:pt>
-                <c:pt idx="6">
-                  <c:v>半导体芯片</c:v>
-                </c:pt>
-                <c:pt idx="7">
+                <c:pt idx="8">
                   <c:v>PCB</c:v>
-                </c:pt>
-                <c:pt idx="8">
-                  <c:v>半导体设备</c:v>
                 </c:pt>
               </c:strCache>
             </c:strRef>
@@ -810,31 +810,31 @@
                 <c:formatCode>General</c:formatCode>
                 <c:ptCount val="9"/>
                 <c:pt idx="0">
-                  <c:v>18.7</c:v>
+                  <c:v>15.0</c:v>
                 </c:pt>
                 <c:pt idx="1">
-                  <c:v>18.3</c:v>
+                  <c:v>14.7</c:v>
                 </c:pt>
                 <c:pt idx="2">
-                  <c:v>16.4</c:v>
+                  <c:v>8.5</c:v>
                 </c:pt>
                 <c:pt idx="3">
-                  <c:v>16.2</c:v>
+                  <c:v>3.3</c:v>
                 </c:pt>
                 <c:pt idx="4">
-                  <c:v>3.3</c:v>
+                  <c:v>0.0</c:v>
                 </c:pt>
                 <c:pt idx="5">
-                  <c:v>1.6</c:v>
+                  <c:v>-5.8</c:v>
                 </c:pt>
                 <c:pt idx="6">
-                  <c:v>-1.9</c:v>
+                  <c:v>-6.2</c:v>
                 </c:pt>
                 <c:pt idx="7">
-                  <c:v>-3.6</c:v>
+                  <c:v>-7.9</c:v>
                 </c:pt>
                 <c:pt idx="8">
-                  <c:v>-6.7</c:v>
+                  <c:v>-12.9</c:v>
                 </c:pt>
               </c:numCache>
             </c:numRef>
@@ -1351,7 +1351,7 @@
           <a:lstStyle/>
           <a:p>
             <a:r>
-              <a:t>当日共 17 个分组；改善 4、恶化 13。转多力度第一为 算力，强度 18.67。最强低位转势候选为 无。</a:t>
+              <a:t>当日共 17 个分组；改善 3、恶化 14。转多力度第一为 机器人，强度 15.00。最强低位转势候选为 无。</a:t>
             </a:r>
           </a:p>
         </p:txBody>
@@ -1561,7 +1561,7 @@
           <a:lstStyle/>
           <a:p>
             <a:r>
-              <a:t>次日先看空转多转多能否继续扩散，再检查空转空转多的蓄势池。反向压力主要来自：电网设备 转空 13 只｜药 转空 11 只｜CPO 转空 8 只｜半导体上游 转空 8 只。</a:t>
+              <a:t>次日先看空转多转多能否继续扩散，再检查空转空转多的蓄势池。反向压力主要来自：电网设备 转空 18 只｜算力 转空 10 只｜药 转空 10 只｜CPO 转空 9 只。</a:t>
             </a:r>
           </a:p>
         </p:txBody>
@@ -4955,7 +4955,7 @@
                 </a:solidFill>
                 <a:latin typeface="Microsoft YaHei"/>
               </a:rPr>
-              <a:t>改善 4 · 恶化 13</a:t>
+              <a:t>改善 3 · 恶化 14</a:t>
             </a:r>
           </a:p>
         </p:txBody>
@@ -5129,7 +5129,7 @@
                 </a:solidFill>
                 <a:latin typeface="Microsoft YaHei"/>
               </a:rPr>
-              <a:t>1</a:t>
+              <a:t>2</a:t>
             </a:r>
           </a:p>
         </p:txBody>
@@ -5345,7 +5345,7 @@
                 </a:solidFill>
                 <a:latin typeface="Microsoft YaHei"/>
               </a:rPr>
-              <a:t>14</a:t>
+              <a:t>15</a:t>
             </a:r>
           </a:p>
         </p:txBody>
@@ -5561,7 +5561,7 @@
                 </a:solidFill>
                 <a:latin typeface="Microsoft YaHei"/>
               </a:rPr>
-              <a:t>算力</a:t>
+              <a:t>机器人</a:t>
             </a:r>
           </a:p>
         </p:txBody>
@@ -5603,7 +5603,7 @@
                 </a:solidFill>
                 <a:latin typeface="Microsoft YaHei"/>
               </a:rPr>
-              <a:t>强度 18.7</a:t>
+              <a:t>强度 15.0</a:t>
             </a:r>
           </a:p>
         </p:txBody>
@@ -5794,7 +5794,7 @@
                 </a:solidFill>
                 <a:latin typeface="Microsoft YaHei"/>
               </a:rPr>
-              <a:t>算力转多确认最强，当前没有满足低位条件的转势候选，但同时提防电网设备、药等反向转空。</a:t>
+              <a:t>机器人转多确认最强，当前没有满足低位条件的转势候选，但同时提防电网设备、算力等反向转空。</a:t>
             </a:r>
           </a:p>
         </p:txBody>
@@ -6052,7 +6052,7 @@
                 </a:solidFill>
                 <a:latin typeface="Microsoft YaHei"/>
               </a:rPr>
-              <a:t>10 只</a:t>
+              <a:t>5 只</a:t>
             </a:r>
           </a:p>
         </p:txBody>
@@ -6181,7 +6181,7 @@
                 </a:solidFill>
                 <a:latin typeface="Microsoft YaHei"/>
               </a:rPr>
-              <a:t>14 个</a:t>
+              <a:t>15 个</a:t>
             </a:r>
           </a:p>
         </p:txBody>
@@ -6609,7 +6609,7 @@
                 </a:solidFill>
                 <a:latin typeface="Microsoft YaHei"/>
               </a:rPr>
-              <a:t>算力</a:t>
+              <a:t>机器人</a:t>
             </a:r>
           </a:p>
         </p:txBody>
@@ -6651,7 +6651,7 @@
                 </a:solidFill>
                 <a:latin typeface="Microsoft YaHei"/>
               </a:rPr>
-              <a:t>空转多→多 9→10 只</a:t>
+              <a:t>空转多→多 23→5 只</a:t>
             </a:r>
           </a:p>
         </p:txBody>
@@ -6782,7 +6782,7 @@
                 </a:solidFill>
                 <a:latin typeface="Microsoft YaHei"/>
               </a:rPr>
-              <a:t>算力</a:t>
+              <a:t>药</a:t>
             </a:r>
           </a:p>
         </p:txBody>
@@ -6824,7 +6824,7 @@
                 </a:solidFill>
                 <a:latin typeface="Microsoft YaHei"/>
               </a:rPr>
-              <a:t>10 只｜多占比 33.3%</a:t>
+              <a:t>7 只｜多占比 15.8%</a:t>
             </a:r>
           </a:p>
         </p:txBody>
@@ -7421,7 +7421,7 @@
                 </a:solidFill>
                 <a:latin typeface="Microsoft YaHei"/>
               </a:rPr>
-              <a:t>算力  ·  18.7</a:t>
+              <a:t>机器人  ·  15.0</a:t>
             </a:r>
           </a:p>
         </p:txBody>
@@ -7587,7 +7587,7 @@
                         </a:defRPr>
                       </a:pPr>
                       <a:r>
-                        <a:t>算力</a:t>
+                        <a:t>机器人</a:t>
                       </a:r>
                     </a:p>
                   </a:txBody>
@@ -7611,7 +7611,7 @@
                         </a:defRPr>
                       </a:pPr>
                       <a:r>
-                        <a:t>18.7</a:t>
+                        <a:t>15.0</a:t>
                       </a:r>
                     </a:p>
                   </a:txBody>
@@ -7635,7 +7635,7 @@
                         </a:defRPr>
                       </a:pPr>
                       <a:r>
-                        <a:t>10只</a:t>
+                        <a:t>5只</a:t>
                       </a:r>
                     </a:p>
                   </a:txBody>
@@ -7685,7 +7685,7 @@
                         </a:defRPr>
                       </a:pPr>
                       <a:r>
-                        <a:t>AI应用</a:t>
+                        <a:t>药</a:t>
                       </a:r>
                     </a:p>
                   </a:txBody>
@@ -7709,7 +7709,7 @@
                         </a:defRPr>
                       </a:pPr>
                       <a:r>
-                        <a:t>18.3</a:t>
+                        <a:t>14.7</a:t>
                       </a:r>
                     </a:p>
                   </a:txBody>
@@ -7733,7 +7733,7 @@
                         </a:defRPr>
                       </a:pPr>
                       <a:r>
-                        <a:t>5只</a:t>
+                        <a:t>7只</a:t>
                       </a:r>
                     </a:p>
                   </a:txBody>
@@ -7783,7 +7783,7 @@
                         </a:defRPr>
                       </a:pPr>
                       <a:r>
-                        <a:t>机器人</a:t>
+                        <a:t>AI应用</a:t>
                       </a:r>
                     </a:p>
                   </a:txBody>
@@ -7807,7 +7807,203 @@
                         </a:defRPr>
                       </a:pPr>
                       <a:r>
-                        <a:t>16.4</a:t>
+                        <a:t>8.5</a:t>
+                      </a:r>
+                    </a:p>
+                  </a:txBody>
+                  <a:tcPr marL="54864" marR="54864">
+                    <a:solidFill>
+                      <a:srgbClr val="FFFFFF"/>
+                    </a:solidFill>
+                  </a:tcPr>
+                </a:tc>
+                <a:tc>
+                  <a:txBody>
+                    <a:bodyPr/>
+                    <a:lstStyle/>
+                    <a:p>
+                      <a:pPr algn="ctr">
+                        <a:defRPr sz="900" b="0">
+                          <a:solidFill>
+                            <a:srgbClr val="233242"/>
+                          </a:solidFill>
+                          <a:latin typeface="Microsoft YaHei"/>
+                        </a:defRPr>
+                      </a:pPr>
+                      <a:r>
+                        <a:t>3只</a:t>
+                      </a:r>
+                    </a:p>
+                  </a:txBody>
+                  <a:tcPr marL="54864" marR="54864">
+                    <a:solidFill>
+                      <a:srgbClr val="FFFFFF"/>
+                    </a:solidFill>
+                  </a:tcPr>
+                </a:tc>
+              </a:tr>
+              <a:tr h="429768">
+                <a:tc>
+                  <a:txBody>
+                    <a:bodyPr/>
+                    <a:lstStyle/>
+                    <a:p>
+                      <a:pPr algn="ctr">
+                        <a:defRPr sz="900" b="0">
+                          <a:solidFill>
+                            <a:srgbClr val="233242"/>
+                          </a:solidFill>
+                          <a:latin typeface="Microsoft YaHei"/>
+                        </a:defRPr>
+                      </a:pPr>
+                      <a:r>
+                        <a:t>4</a:t>
+                      </a:r>
+                    </a:p>
+                  </a:txBody>
+                  <a:tcPr marL="54864" marR="54864">
+                    <a:solidFill>
+                      <a:srgbClr val="F7F9FC"/>
+                    </a:solidFill>
+                  </a:tcPr>
+                </a:tc>
+                <a:tc>
+                  <a:txBody>
+                    <a:bodyPr/>
+                    <a:lstStyle/>
+                    <a:p>
+                      <a:pPr algn="l">
+                        <a:defRPr sz="900" b="1">
+                          <a:solidFill>
+                            <a:srgbClr val="233242"/>
+                          </a:solidFill>
+                          <a:latin typeface="Microsoft YaHei"/>
+                        </a:defRPr>
+                      </a:pPr>
+                      <a:r>
+                        <a:t>互金证券</a:t>
+                      </a:r>
+                    </a:p>
+                  </a:txBody>
+                  <a:tcPr marL="54864" marR="54864">
+                    <a:solidFill>
+                      <a:srgbClr val="F7F9FC"/>
+                    </a:solidFill>
+                  </a:tcPr>
+                </a:tc>
+                <a:tc>
+                  <a:txBody>
+                    <a:bodyPr/>
+                    <a:lstStyle/>
+                    <a:p>
+                      <a:pPr algn="ctr">
+                        <a:defRPr sz="900" b="0">
+                          <a:solidFill>
+                            <a:srgbClr val="D34347"/>
+                          </a:solidFill>
+                          <a:latin typeface="Microsoft YaHei"/>
+                        </a:defRPr>
+                      </a:pPr>
+                      <a:r>
+                        <a:t>3.3</a:t>
+                      </a:r>
+                    </a:p>
+                  </a:txBody>
+                  <a:tcPr marL="54864" marR="54864">
+                    <a:solidFill>
+                      <a:srgbClr val="F7F9FC"/>
+                    </a:solidFill>
+                  </a:tcPr>
+                </a:tc>
+                <a:tc>
+                  <a:txBody>
+                    <a:bodyPr/>
+                    <a:lstStyle/>
+                    <a:p>
+                      <a:pPr algn="ctr">
+                        <a:defRPr sz="900" b="0">
+                          <a:solidFill>
+                            <a:srgbClr val="233242"/>
+                          </a:solidFill>
+                          <a:latin typeface="Microsoft YaHei"/>
+                        </a:defRPr>
+                      </a:pPr>
+                      <a:r>
+                        <a:t>1只</a:t>
+                      </a:r>
+                    </a:p>
+                  </a:txBody>
+                  <a:tcPr marL="54864" marR="54864">
+                    <a:solidFill>
+                      <a:srgbClr val="F7F9FC"/>
+                    </a:solidFill>
+                  </a:tcPr>
+                </a:tc>
+              </a:tr>
+              <a:tr h="429768">
+                <a:tc>
+                  <a:txBody>
+                    <a:bodyPr/>
+                    <a:lstStyle/>
+                    <a:p>
+                      <a:pPr algn="ctr">
+                        <a:defRPr sz="900" b="0">
+                          <a:solidFill>
+                            <a:srgbClr val="233242"/>
+                          </a:solidFill>
+                          <a:latin typeface="Microsoft YaHei"/>
+                        </a:defRPr>
+                      </a:pPr>
+                      <a:r>
+                        <a:t>5</a:t>
+                      </a:r>
+                    </a:p>
+                  </a:txBody>
+                  <a:tcPr marL="54864" marR="54864">
+                    <a:solidFill>
+                      <a:srgbClr val="FFFFFF"/>
+                    </a:solidFill>
+                  </a:tcPr>
+                </a:tc>
+                <a:tc>
+                  <a:txBody>
+                    <a:bodyPr/>
+                    <a:lstStyle/>
+                    <a:p>
+                      <a:pPr algn="l">
+                        <a:defRPr sz="900" b="1">
+                          <a:solidFill>
+                            <a:srgbClr val="233242"/>
+                          </a:solidFill>
+                          <a:latin typeface="Microsoft YaHei"/>
+                        </a:defRPr>
+                      </a:pPr>
+                      <a:r>
+                        <a:t>算力</a:t>
+                      </a:r>
+                    </a:p>
+                  </a:txBody>
+                  <a:tcPr marL="54864" marR="54864">
+                    <a:solidFill>
+                      <a:srgbClr val="FFFFFF"/>
+                    </a:solidFill>
+                  </a:tcPr>
+                </a:tc>
+                <a:tc>
+                  <a:txBody>
+                    <a:bodyPr/>
+                    <a:lstStyle/>
+                    <a:p>
+                      <a:pPr algn="ctr">
+                        <a:defRPr sz="900" b="0">
+                          <a:solidFill>
+                            <a:srgbClr val="D34347"/>
+                          </a:solidFill>
+                          <a:latin typeface="Microsoft YaHei"/>
+                        </a:defRPr>
+                      </a:pPr>
+                      <a:r>
+                        <a:t>0.0</a:t>
                       </a:r>
                     </a:p>
                   </a:txBody>
@@ -7857,202 +8053,6 @@
                         </a:defRPr>
                       </a:pPr>
                       <a:r>
-                        <a:t>4</a:t>
-                      </a:r>
-                    </a:p>
-                  </a:txBody>
-                  <a:tcPr marL="54864" marR="54864">
-                    <a:solidFill>
-                      <a:srgbClr val="F7F9FC"/>
-                    </a:solidFill>
-                  </a:tcPr>
-                </a:tc>
-                <a:tc>
-                  <a:txBody>
-                    <a:bodyPr/>
-                    <a:lstStyle/>
-                    <a:p>
-                      <a:pPr algn="l">
-                        <a:defRPr sz="900" b="1">
-                          <a:solidFill>
-                            <a:srgbClr val="233242"/>
-                          </a:solidFill>
-                          <a:latin typeface="Microsoft YaHei"/>
-                        </a:defRPr>
-                      </a:pPr>
-                      <a:r>
-                        <a:t>药</a:t>
-                      </a:r>
-                    </a:p>
-                  </a:txBody>
-                  <a:tcPr marL="54864" marR="54864">
-                    <a:solidFill>
-                      <a:srgbClr val="F7F9FC"/>
-                    </a:solidFill>
-                  </a:tcPr>
-                </a:tc>
-                <a:tc>
-                  <a:txBody>
-                    <a:bodyPr/>
-                    <a:lstStyle/>
-                    <a:p>
-                      <a:pPr algn="ctr">
-                        <a:defRPr sz="900" b="0">
-                          <a:solidFill>
-                            <a:srgbClr val="D34347"/>
-                          </a:solidFill>
-                          <a:latin typeface="Microsoft YaHei"/>
-                        </a:defRPr>
-                      </a:pPr>
-                      <a:r>
-                        <a:t>16.2</a:t>
-                      </a:r>
-                    </a:p>
-                  </a:txBody>
-                  <a:tcPr marL="54864" marR="54864">
-                    <a:solidFill>
-                      <a:srgbClr val="F7F9FC"/>
-                    </a:solidFill>
-                  </a:tcPr>
-                </a:tc>
-                <a:tc>
-                  <a:txBody>
-                    <a:bodyPr/>
-                    <a:lstStyle/>
-                    <a:p>
-                      <a:pPr algn="ctr">
-                        <a:defRPr sz="900" b="0">
-                          <a:solidFill>
-                            <a:srgbClr val="233242"/>
-                          </a:solidFill>
-                          <a:latin typeface="Microsoft YaHei"/>
-                        </a:defRPr>
-                      </a:pPr>
-                      <a:r>
-                        <a:t>8只</a:t>
-                      </a:r>
-                    </a:p>
-                  </a:txBody>
-                  <a:tcPr marL="54864" marR="54864">
-                    <a:solidFill>
-                      <a:srgbClr val="F7F9FC"/>
-                    </a:solidFill>
-                  </a:tcPr>
-                </a:tc>
-              </a:tr>
-              <a:tr h="429768">
-                <a:tc>
-                  <a:txBody>
-                    <a:bodyPr/>
-                    <a:lstStyle/>
-                    <a:p>
-                      <a:pPr algn="ctr">
-                        <a:defRPr sz="900" b="0">
-                          <a:solidFill>
-                            <a:srgbClr val="233242"/>
-                          </a:solidFill>
-                          <a:latin typeface="Microsoft YaHei"/>
-                        </a:defRPr>
-                      </a:pPr>
-                      <a:r>
-                        <a:t>5</a:t>
-                      </a:r>
-                    </a:p>
-                  </a:txBody>
-                  <a:tcPr marL="54864" marR="54864">
-                    <a:solidFill>
-                      <a:srgbClr val="FFFFFF"/>
-                    </a:solidFill>
-                  </a:tcPr>
-                </a:tc>
-                <a:tc>
-                  <a:txBody>
-                    <a:bodyPr/>
-                    <a:lstStyle/>
-                    <a:p>
-                      <a:pPr algn="l">
-                        <a:defRPr sz="900" b="1">
-                          <a:solidFill>
-                            <a:srgbClr val="233242"/>
-                          </a:solidFill>
-                          <a:latin typeface="Microsoft YaHei"/>
-                        </a:defRPr>
-                      </a:pPr>
-                      <a:r>
-                        <a:t>互金证券</a:t>
-                      </a:r>
-                    </a:p>
-                  </a:txBody>
-                  <a:tcPr marL="54864" marR="54864">
-                    <a:solidFill>
-                      <a:srgbClr val="FFFFFF"/>
-                    </a:solidFill>
-                  </a:tcPr>
-                </a:tc>
-                <a:tc>
-                  <a:txBody>
-                    <a:bodyPr/>
-                    <a:lstStyle/>
-                    <a:p>
-                      <a:pPr algn="ctr">
-                        <a:defRPr sz="900" b="0">
-                          <a:solidFill>
-                            <a:srgbClr val="D34347"/>
-                          </a:solidFill>
-                          <a:latin typeface="Microsoft YaHei"/>
-                        </a:defRPr>
-                      </a:pPr>
-                      <a:r>
-                        <a:t>3.3</a:t>
-                      </a:r>
-                    </a:p>
-                  </a:txBody>
-                  <a:tcPr marL="54864" marR="54864">
-                    <a:solidFill>
-                      <a:srgbClr val="FFFFFF"/>
-                    </a:solidFill>
-                  </a:tcPr>
-                </a:tc>
-                <a:tc>
-                  <a:txBody>
-                    <a:bodyPr/>
-                    <a:lstStyle/>
-                    <a:p>
-                      <a:pPr algn="ctr">
-                        <a:defRPr sz="900" b="0">
-                          <a:solidFill>
-                            <a:srgbClr val="233242"/>
-                          </a:solidFill>
-                          <a:latin typeface="Microsoft YaHei"/>
-                        </a:defRPr>
-                      </a:pPr>
-                      <a:r>
-                        <a:t>2只</a:t>
-                      </a:r>
-                    </a:p>
-                  </a:txBody>
-                  <a:tcPr marL="54864" marR="54864">
-                    <a:solidFill>
-                      <a:srgbClr val="FFFFFF"/>
-                    </a:solidFill>
-                  </a:tcPr>
-                </a:tc>
-              </a:tr>
-              <a:tr h="429768">
-                <a:tc>
-                  <a:txBody>
-                    <a:bodyPr/>
-                    <a:lstStyle/>
-                    <a:p>
-                      <a:pPr algn="ctr">
-                        <a:defRPr sz="900" b="0">
-                          <a:solidFill>
-                            <a:srgbClr val="233242"/>
-                          </a:solidFill>
-                          <a:latin typeface="Microsoft YaHei"/>
-                        </a:defRPr>
-                      </a:pPr>
-                      <a:r>
                         <a:t>6</a:t>
                       </a:r>
                     </a:p>
@@ -8077,7 +8077,7 @@
                         </a:defRPr>
                       </a:pPr>
                       <a:r>
-                        <a:t>商业航天</a:t>
+                        <a:t>半导体芯片</a:t>
                       </a:r>
                     </a:p>
                   </a:txBody>
@@ -8101,7 +8101,7 @@
                         </a:defRPr>
                       </a:pPr>
                       <a:r>
-                        <a:t>1.6</a:t>
+                        <a:t>-5.8</a:t>
                       </a:r>
                     </a:p>
                   </a:txBody>
@@ -8588,7 +8588,7 @@
                 </a:solidFill>
                 <a:latin typeface="Microsoft YaHei"/>
               </a:rPr>
-              <a:t>算力</a:t>
+              <a:t>机器人</a:t>
             </a:r>
           </a:p>
         </p:txBody>
@@ -8630,7 +8630,7 @@
                 </a:solidFill>
                 <a:latin typeface="Microsoft YaHei"/>
               </a:rPr>
-              <a:t>18.7 分</a:t>
+              <a:t>15.0 分</a:t>
             </a:r>
           </a:p>
         </p:txBody>
@@ -8672,7 +8672,7 @@
                 </a:solidFill>
                 <a:latin typeface="Microsoft YaHei"/>
               </a:rPr>
-              <a:t>空转多→多 9→10；反向转空 8 只</a:t>
+              <a:t>空转多→多 23→5；反向转空 3 只</a:t>
             </a:r>
           </a:p>
         </p:txBody>
@@ -8714,7 +8714,7 @@
                 </a:solidFill>
                 <a:latin typeface="Microsoft YaHei"/>
               </a:rPr>
-              <a:t>空转多→多 10 只｜空→空转多 2 只｜多占比 33.3%</a:t>
+              <a:t>空转多→多 5 只｜空→空转多 4 只｜多占比 75.7%</a:t>
             </a:r>
           </a:p>
         </p:txBody>
@@ -8781,7 +8781,7 @@
             <a:avLst/>
           </a:prstGeom>
           <a:solidFill>
-            <a:srgbClr val="E88B36"/>
+            <a:srgbClr val="D34347"/>
           </a:solidFill>
           <a:ln>
             <a:noFill/>
@@ -8846,7 +8846,7 @@
                 </a:solidFill>
                 <a:latin typeface="Microsoft YaHei"/>
               </a:rPr>
-              <a:t>AI应用</a:t>
+              <a:t>药</a:t>
             </a:r>
           </a:p>
         </p:txBody>
@@ -8884,11 +8884,11 @@
             <a:r>
               <a:rPr sz="950" b="1" i="0">
                 <a:solidFill>
-                  <a:srgbClr val="E88B36"/>
+                  <a:srgbClr val="D34347"/>
                 </a:solidFill>
                 <a:latin typeface="Microsoft YaHei"/>
               </a:rPr>
-              <a:t>18.3 分</a:t>
+              <a:t>14.7 分</a:t>
             </a:r>
           </a:p>
         </p:txBody>
@@ -8930,7 +8930,7 @@
                 </a:solidFill>
                 <a:latin typeface="Microsoft YaHei"/>
               </a:rPr>
-              <a:t>空转多→多 5→5；反向转空 5 只</a:t>
+              <a:t>空→多跳级 1 只；空转多→多 3→7；反向转空 10 只</a:t>
             </a:r>
           </a:p>
         </p:txBody>
@@ -8972,7 +8972,7 @@
                 </a:solidFill>
                 <a:latin typeface="Microsoft YaHei"/>
               </a:rPr>
-              <a:t>空转多→多 5 只｜空→空转多 8 只｜多占比 33.8%</a:t>
+              <a:t>空转多→多 7 只｜空→空转多 14 只｜多占比 15.8%</a:t>
             </a:r>
           </a:p>
         </p:txBody>
@@ -9104,7 +9104,7 @@
                 </a:solidFill>
                 <a:latin typeface="Microsoft YaHei"/>
               </a:rPr>
-              <a:t>机器人</a:t>
+              <a:t>AI应用</a:t>
             </a:r>
           </a:p>
         </p:txBody>
@@ -9146,7 +9146,7 @@
                 </a:solidFill>
                 <a:latin typeface="Microsoft YaHei"/>
               </a:rPr>
-              <a:t>16.4 分</a:t>
+              <a:t>8.5 分</a:t>
             </a:r>
           </a:p>
         </p:txBody>
@@ -9188,7 +9188,7 @@
                 </a:solidFill>
                 <a:latin typeface="Microsoft YaHei"/>
               </a:rPr>
-              <a:t>空转多→多 23→5；反向转空 2 只</a:t>
+              <a:t>空转多→多 5→3；反向转空 6 只</a:t>
             </a:r>
           </a:p>
         </p:txBody>
@@ -9230,7 +9230,7 @@
                 </a:solidFill>
                 <a:latin typeface="Microsoft YaHei"/>
               </a:rPr>
-              <a:t>空转多→多 5 只｜空→空转多 4 只｜多占比 75.7%</a:t>
+              <a:t>空转多→多 3 只｜空→空转多 6 只｜多占比 29.6%</a:t>
             </a:r>
           </a:p>
         </p:txBody>
@@ -9297,7 +9297,7 @@
             <a:avLst/>
           </a:prstGeom>
           <a:solidFill>
-            <a:srgbClr val="D34347"/>
+            <a:srgbClr val="E88B36"/>
           </a:solidFill>
           <a:ln>
             <a:noFill/>
@@ -9362,7 +9362,7 @@
                 </a:solidFill>
                 <a:latin typeface="Microsoft YaHei"/>
               </a:rPr>
-              <a:t>药</a:t>
+              <a:t>互金证券</a:t>
             </a:r>
           </a:p>
         </p:txBody>
@@ -9400,11 +9400,11 @@
             <a:r>
               <a:rPr sz="950" b="1" i="0">
                 <a:solidFill>
-                  <a:srgbClr val="D34347"/>
+                  <a:srgbClr val="E88B36"/>
                 </a:solidFill>
                 <a:latin typeface="Microsoft YaHei"/>
               </a:rPr>
-              <a:t>16.2 分</a:t>
+              <a:t>3.3 分</a:t>
             </a:r>
           </a:p>
         </p:txBody>
@@ -9446,7 +9446,7 @@
                 </a:solidFill>
                 <a:latin typeface="Microsoft YaHei"/>
               </a:rPr>
-              <a:t>空→多跳级 1 只；空转多→多 3→8；反向转空 11 只</a:t>
+              <a:t>空转多→多 0→1；反向转空 3 只</a:t>
             </a:r>
           </a:p>
         </p:txBody>
@@ -9488,7 +9488,7 @@
                 </a:solidFill>
                 <a:latin typeface="Microsoft YaHei"/>
               </a:rPr>
-              <a:t>空转多→多 8 只｜空→空转多 15 只｜多占比 16.5%</a:t>
+              <a:t>空转多→多 1 只｜空→空转多 3 只｜多占比 5.0%</a:t>
             </a:r>
           </a:p>
         </p:txBody>
@@ -9620,7 +9620,7 @@
                 </a:solidFill>
                 <a:latin typeface="Microsoft YaHei"/>
               </a:rPr>
-              <a:t>互金证券</a:t>
+              <a:t>算力</a:t>
             </a:r>
           </a:p>
         </p:txBody>
@@ -9662,7 +9662,7 @@
                 </a:solidFill>
                 <a:latin typeface="Microsoft YaHei"/>
               </a:rPr>
-              <a:t>3.3 分</a:t>
+              <a:t>0.0 分</a:t>
             </a:r>
           </a:p>
         </p:txBody>
@@ -9704,7 +9704,7 @@
                 </a:solidFill>
                 <a:latin typeface="Microsoft YaHei"/>
               </a:rPr>
-              <a:t>空转多→多 0→2；反向转空 3 只</a:t>
+              <a:t>空转多→多 9→5；反向转空 10 只</a:t>
             </a:r>
           </a:p>
         </p:txBody>
@@ -9746,7 +9746,7 @@
                 </a:solidFill>
                 <a:latin typeface="Microsoft YaHei"/>
               </a:rPr>
-              <a:t>空转多→多 2 只｜空→空转多 1 只｜多占比 6.7%</a:t>
+              <a:t>空转多→多 5 只｜空→空转多 0 只｜多占比 25.3%</a:t>
             </a:r>
           </a:p>
         </p:txBody>
@@ -9878,7 +9878,7 @@
                 </a:solidFill>
                 <a:latin typeface="Microsoft YaHei"/>
               </a:rPr>
-              <a:t>商业航天</a:t>
+              <a:t>半导体芯片</a:t>
             </a:r>
           </a:p>
         </p:txBody>
@@ -9920,7 +9920,7 @@
                 </a:solidFill>
                 <a:latin typeface="Microsoft YaHei"/>
               </a:rPr>
-              <a:t>1.6 分</a:t>
+              <a:t>-5.8 分</a:t>
             </a:r>
           </a:p>
         </p:txBody>
@@ -9962,7 +9962,7 @@
                 </a:solidFill>
                 <a:latin typeface="Microsoft YaHei"/>
               </a:rPr>
-              <a:t>空转多→多 9→2；反向转空 6 只</a:t>
+              <a:t>空转多→多 7→2；反向转空 8 只</a:t>
             </a:r>
           </a:p>
         </p:txBody>
@@ -10004,7 +10004,7 @@
                 </a:solidFill>
                 <a:latin typeface="Microsoft YaHei"/>
               </a:rPr>
-              <a:t>空转多→多 2 只｜空→空转多 4 只｜多占比 19.0%</a:t>
+              <a:t>空转多→多 2 只｜空→空转多 1 只｜多占比 15.4%</a:t>
             </a:r>
           </a:p>
         </p:txBody>
@@ -10133,7 +10133,7 @@
                 </a:solidFill>
                 <a:latin typeface="Microsoft YaHei"/>
               </a:rPr>
-              <a:t>电网设备 转空 13 只｜药 转空 11 只｜CPO 转空 8 只｜半导体上游 转空 8 只</a:t>
+              <a:t>电网设备 转空 18 只｜算力 转空 10 只｜药 转空 10 只｜CPO 转空 9 只</a:t>
             </a:r>
           </a:p>
         </p:txBody>

</xml_diff>